<commit_message>
add ss of dashboard
</commit_message>
<xml_diff>
--- a/retail_store_analysis/Retail_Store_Analysis_Shanib.pptx
+++ b/retail_store_analysis/Retail_Store_Analysis_Shanib.pptx
@@ -69,24 +69,25 @@
             <a:noAutofit/>
           </a:bodyPr>
           <a:p>
-            <a:r>
-              <a:rPr lang="en-US" sz="1800" b="0" u="none" strike="noStrike">
-                <a:solidFill>
-                  <a:schemeClr val="dk1"/>
-                </a:solidFill>
-                <a:effectLst/>
-                <a:uFillTx/>
-                <a:latin typeface="Calibri"/>
+            <a:pPr algn="ctr"/>
+            <a:r>
+              <a:rPr lang="en-US" sz="4400" b="0" u="none" strike="noStrike">
+                <a:solidFill>
+                  <a:srgbClr val="000000"/>
+                </a:solidFill>
+                <a:effectLst/>
+                <a:uFillTx/>
+                <a:latin typeface="Arial"/>
               </a:rPr>
               <a:t>Click to move the slide</a:t>
             </a:r>
-            <a:endParaRPr lang="en-US" sz="1800" b="0" u="none" strike="noStrike">
-              <a:solidFill>
-                <a:schemeClr val="dk1"/>
-              </a:solidFill>
-              <a:effectLst/>
-              <a:uFillTx/>
-              <a:latin typeface="Calibri"/>
+            <a:endParaRPr lang="en-US" sz="4400" b="0" u="none" strike="noStrike">
+              <a:solidFill>
+                <a:srgbClr val="000000"/>
+              </a:solidFill>
+              <a:effectLst/>
+              <a:uFillTx/>
+              <a:latin typeface="Arial"/>
             </a:endParaRPr>
           </a:p>
         </p:txBody>
@@ -373,7 +374,7 @@
             <a:pPr indent="0" algn="r">
               <a:buNone/>
             </a:pPr>
-            <a:fld id="{56FA9A8F-7D3B-4140-8069-7574D7F31993}" type="slidenum">
+            <a:fld id="{7E8159DA-FCBD-4AF1-A383-61A5564728B5}" type="slidenum">
               <a:rPr lang="en-US" sz="1400" b="0" u="none" strike="noStrike">
                 <a:solidFill>
                   <a:srgbClr val="000000"/>
@@ -431,7 +432,7 @@
         <p:spPr>
           <a:xfrm>
             <a:off x="685800" y="1143000"/>
-            <a:ext cx="5486040" cy="3085920"/>
+            <a:ext cx="5485680" cy="3085560"/>
           </a:xfrm>
           <a:prstGeom prst="rect">
             <a:avLst/>
@@ -454,7 +455,7 @@
         <p:spPr>
           <a:xfrm>
             <a:off x="685800" y="4400640"/>
-            <a:ext cx="5486040" cy="3600000"/>
+            <a:ext cx="5485680" cy="3599640"/>
           </a:xfrm>
           <a:prstGeom prst="rect">
             <a:avLst/>
@@ -496,7 +497,7 @@
         <p:spPr>
           <a:xfrm>
             <a:off x="3884760" y="8685360"/>
-            <a:ext cx="2971440" cy="458280"/>
+            <a:ext cx="2971080" cy="457920"/>
           </a:xfrm>
           <a:prstGeom prst="rect">
             <a:avLst/>
@@ -516,6 +517,9 @@
                 <a:spcPct val="100000"/>
               </a:lnSpc>
               <a:buNone/>
+              <a:tabLst>
+                <a:tab pos="0" algn="l"/>
+              </a:tabLst>
               <a:defRPr lang="en-US" sz="1200" b="0" u="none" strike="noStrike">
                 <a:solidFill>
                   <a:schemeClr val="dk1"/>
@@ -533,8 +537,11 @@
                 <a:spcPct val="100000"/>
               </a:lnSpc>
               <a:buNone/>
-            </a:pPr>
-            <a:fld id="{95A95D80-A436-4093-809F-35A4C035DB03}" type="slidenum">
+              <a:tabLst>
+                <a:tab pos="0" algn="l"/>
+              </a:tabLst>
+            </a:pPr>
+            <a:fld id="{9E1C7A4C-CD63-422A-8687-114E95481F1A}" type="slidenum">
               <a:rPr lang="en-US" sz="1200" b="0" u="none" strike="noStrike">
                 <a:solidFill>
                   <a:schemeClr val="dk1"/>
@@ -592,7 +599,7 @@
         <p:spPr>
           <a:xfrm>
             <a:off x="685800" y="1143000"/>
-            <a:ext cx="5486040" cy="3085920"/>
+            <a:ext cx="5485680" cy="3085560"/>
           </a:xfrm>
           <a:prstGeom prst="rect">
             <a:avLst/>
@@ -615,7 +622,7 @@
         <p:spPr>
           <a:xfrm>
             <a:off x="685800" y="4400640"/>
-            <a:ext cx="5486040" cy="3600000"/>
+            <a:ext cx="5485680" cy="3599640"/>
           </a:xfrm>
           <a:prstGeom prst="rect">
             <a:avLst/>
@@ -657,7 +664,7 @@
         <p:spPr>
           <a:xfrm>
             <a:off x="3884760" y="8685360"/>
-            <a:ext cx="2971440" cy="458280"/>
+            <a:ext cx="2971080" cy="457920"/>
           </a:xfrm>
           <a:prstGeom prst="rect">
             <a:avLst/>
@@ -677,6 +684,9 @@
                 <a:spcPct val="100000"/>
               </a:lnSpc>
               <a:buNone/>
+              <a:tabLst>
+                <a:tab pos="0" algn="l"/>
+              </a:tabLst>
               <a:defRPr lang="en-US" sz="1200" b="0" u="none" strike="noStrike">
                 <a:solidFill>
                   <a:schemeClr val="dk1"/>
@@ -694,8 +704,11 @@
                 <a:spcPct val="100000"/>
               </a:lnSpc>
               <a:buNone/>
-            </a:pPr>
-            <a:fld id="{18BD4565-76A8-491E-8F82-A2B1F1DCE13B}" type="slidenum">
+              <a:tabLst>
+                <a:tab pos="0" algn="l"/>
+              </a:tabLst>
+            </a:pPr>
+            <a:fld id="{884B2C00-BAB7-4362-8E34-54A1BBA725BD}" type="slidenum">
               <a:rPr lang="en-US" sz="1200" b="0" u="none" strike="noStrike">
                 <a:solidFill>
                   <a:schemeClr val="dk1"/>
@@ -753,7 +766,7 @@
         <p:spPr>
           <a:xfrm>
             <a:off x="685800" y="1143000"/>
-            <a:ext cx="5486040" cy="3085920"/>
+            <a:ext cx="5485680" cy="3085560"/>
           </a:xfrm>
           <a:prstGeom prst="rect">
             <a:avLst/>
@@ -776,7 +789,7 @@
         <p:spPr>
           <a:xfrm>
             <a:off x="685800" y="4400640"/>
-            <a:ext cx="5486040" cy="3600000"/>
+            <a:ext cx="5485680" cy="3599640"/>
           </a:xfrm>
           <a:prstGeom prst="rect">
             <a:avLst/>
@@ -818,7 +831,7 @@
         <p:spPr>
           <a:xfrm>
             <a:off x="3884760" y="8685360"/>
-            <a:ext cx="2971440" cy="458280"/>
+            <a:ext cx="2971080" cy="457920"/>
           </a:xfrm>
           <a:prstGeom prst="rect">
             <a:avLst/>
@@ -838,6 +851,9 @@
                 <a:spcPct val="100000"/>
               </a:lnSpc>
               <a:buNone/>
+              <a:tabLst>
+                <a:tab pos="0" algn="l"/>
+              </a:tabLst>
               <a:defRPr lang="en-US" sz="1200" b="0" u="none" strike="noStrike">
                 <a:solidFill>
                   <a:schemeClr val="dk1"/>
@@ -855,8 +871,11 @@
                 <a:spcPct val="100000"/>
               </a:lnSpc>
               <a:buNone/>
-            </a:pPr>
-            <a:fld id="{F2631384-562B-4C9F-9172-F4E354F816F3}" type="slidenum">
+              <a:tabLst>
+                <a:tab pos="0" algn="l"/>
+              </a:tabLst>
+            </a:pPr>
+            <a:fld id="{09E80FD9-AD21-410B-8043-BAC827C6E0CE}" type="slidenum">
               <a:rPr lang="en-US" sz="1200" b="0" u="none" strike="noStrike">
                 <a:solidFill>
                   <a:schemeClr val="dk1"/>
@@ -914,7 +933,7 @@
         <p:spPr>
           <a:xfrm>
             <a:off x="685800" y="1143000"/>
-            <a:ext cx="5486040" cy="3085920"/>
+            <a:ext cx="5485680" cy="3085560"/>
           </a:xfrm>
           <a:prstGeom prst="rect">
             <a:avLst/>
@@ -937,7 +956,7 @@
         <p:spPr>
           <a:xfrm>
             <a:off x="685800" y="4400640"/>
-            <a:ext cx="5486040" cy="3600000"/>
+            <a:ext cx="5485680" cy="3599640"/>
           </a:xfrm>
           <a:prstGeom prst="rect">
             <a:avLst/>
@@ -979,7 +998,7 @@
         <p:spPr>
           <a:xfrm>
             <a:off x="3884760" y="8685360"/>
-            <a:ext cx="2971440" cy="458280"/>
+            <a:ext cx="2971080" cy="457920"/>
           </a:xfrm>
           <a:prstGeom prst="rect">
             <a:avLst/>
@@ -999,6 +1018,9 @@
                 <a:spcPct val="100000"/>
               </a:lnSpc>
               <a:buNone/>
+              <a:tabLst>
+                <a:tab pos="0" algn="l"/>
+              </a:tabLst>
               <a:defRPr lang="en-US" sz="1200" b="0" u="none" strike="noStrike">
                 <a:solidFill>
                   <a:schemeClr val="dk1"/>
@@ -1016,8 +1038,11 @@
                 <a:spcPct val="100000"/>
               </a:lnSpc>
               <a:buNone/>
-            </a:pPr>
-            <a:fld id="{FBBC6FEF-D9BA-4E84-A6FC-BB2642AFD37E}" type="slidenum">
+              <a:tabLst>
+                <a:tab pos="0" algn="l"/>
+              </a:tabLst>
+            </a:pPr>
+            <a:fld id="{2F77EDA2-B63B-4178-AC4F-903951577436}" type="slidenum">
               <a:rPr lang="en-US" sz="1200" b="0" u="none" strike="noStrike">
                 <a:solidFill>
                   <a:schemeClr val="dk1"/>
@@ -1075,7 +1100,7 @@
         <p:spPr>
           <a:xfrm>
             <a:off x="685800" y="1143000"/>
-            <a:ext cx="5486040" cy="3085920"/>
+            <a:ext cx="5485680" cy="3085560"/>
           </a:xfrm>
           <a:prstGeom prst="rect">
             <a:avLst/>
@@ -1098,7 +1123,7 @@
         <p:spPr>
           <a:xfrm>
             <a:off x="685800" y="4400640"/>
-            <a:ext cx="5486040" cy="3600000"/>
+            <a:ext cx="5485680" cy="3599640"/>
           </a:xfrm>
           <a:prstGeom prst="rect">
             <a:avLst/>
@@ -1140,7 +1165,7 @@
         <p:spPr>
           <a:xfrm>
             <a:off x="3884760" y="8685360"/>
-            <a:ext cx="2971440" cy="458280"/>
+            <a:ext cx="2971080" cy="457920"/>
           </a:xfrm>
           <a:prstGeom prst="rect">
             <a:avLst/>
@@ -1160,6 +1185,9 @@
                 <a:spcPct val="100000"/>
               </a:lnSpc>
               <a:buNone/>
+              <a:tabLst>
+                <a:tab pos="0" algn="l"/>
+              </a:tabLst>
               <a:defRPr lang="en-US" sz="1200" b="0" u="none" strike="noStrike">
                 <a:solidFill>
                   <a:schemeClr val="dk1"/>
@@ -1177,8 +1205,11 @@
                 <a:spcPct val="100000"/>
               </a:lnSpc>
               <a:buNone/>
-            </a:pPr>
-            <a:fld id="{63656963-644F-4EB4-A3FF-703262C24EF4}" type="slidenum">
+              <a:tabLst>
+                <a:tab pos="0" algn="l"/>
+              </a:tabLst>
+            </a:pPr>
+            <a:fld id="{26828BAA-01F0-4123-BAF3-37D93AC06342}" type="slidenum">
               <a:rPr lang="en-US" sz="1200" b="0" u="none" strike="noStrike">
                 <a:solidFill>
                   <a:schemeClr val="dk1"/>
@@ -1236,7 +1267,7 @@
         <p:spPr>
           <a:xfrm>
             <a:off x="685800" y="1143000"/>
-            <a:ext cx="5486040" cy="3085920"/>
+            <a:ext cx="5485680" cy="3085560"/>
           </a:xfrm>
           <a:prstGeom prst="rect">
             <a:avLst/>
@@ -1259,7 +1290,7 @@
         <p:spPr>
           <a:xfrm>
             <a:off x="685800" y="4400640"/>
-            <a:ext cx="5486040" cy="3600000"/>
+            <a:ext cx="5485680" cy="3599640"/>
           </a:xfrm>
           <a:prstGeom prst="rect">
             <a:avLst/>
@@ -1301,7 +1332,7 @@
         <p:spPr>
           <a:xfrm>
             <a:off x="3884760" y="8685360"/>
-            <a:ext cx="2971440" cy="458280"/>
+            <a:ext cx="2971080" cy="457920"/>
           </a:xfrm>
           <a:prstGeom prst="rect">
             <a:avLst/>
@@ -1321,6 +1352,9 @@
                 <a:spcPct val="100000"/>
               </a:lnSpc>
               <a:buNone/>
+              <a:tabLst>
+                <a:tab pos="0" algn="l"/>
+              </a:tabLst>
               <a:defRPr lang="en-US" sz="1200" b="0" u="none" strike="noStrike">
                 <a:solidFill>
                   <a:schemeClr val="dk1"/>
@@ -1338,8 +1372,11 @@
                 <a:spcPct val="100000"/>
               </a:lnSpc>
               <a:buNone/>
-            </a:pPr>
-            <a:fld id="{5919C77A-3EAF-440C-B4BD-066AB52C014D}" type="slidenum">
+              <a:tabLst>
+                <a:tab pos="0" algn="l"/>
+              </a:tabLst>
+            </a:pPr>
+            <a:fld id="{09DB8DC9-84E2-4BAB-A408-E5229CFA7328}" type="slidenum">
               <a:rPr lang="en-US" sz="1200" b="0" u="none" strike="noStrike">
                 <a:solidFill>
                   <a:schemeClr val="dk1"/>
@@ -1397,7 +1434,7 @@
         <p:spPr>
           <a:xfrm>
             <a:off x="685800" y="1143000"/>
-            <a:ext cx="5486040" cy="3085920"/>
+            <a:ext cx="5485680" cy="3085560"/>
           </a:xfrm>
           <a:prstGeom prst="rect">
             <a:avLst/>
@@ -1420,7 +1457,7 @@
         <p:spPr>
           <a:xfrm>
             <a:off x="685800" y="4400640"/>
-            <a:ext cx="5486040" cy="3600000"/>
+            <a:ext cx="5485680" cy="3599640"/>
           </a:xfrm>
           <a:prstGeom prst="rect">
             <a:avLst/>
@@ -1462,7 +1499,7 @@
         <p:spPr>
           <a:xfrm>
             <a:off x="3884760" y="8685360"/>
-            <a:ext cx="2971440" cy="458280"/>
+            <a:ext cx="2971080" cy="457920"/>
           </a:xfrm>
           <a:prstGeom prst="rect">
             <a:avLst/>
@@ -1482,6 +1519,9 @@
                 <a:spcPct val="100000"/>
               </a:lnSpc>
               <a:buNone/>
+              <a:tabLst>
+                <a:tab pos="0" algn="l"/>
+              </a:tabLst>
               <a:defRPr lang="en-US" sz="1200" b="0" u="none" strike="noStrike">
                 <a:solidFill>
                   <a:schemeClr val="dk1"/>
@@ -1499,8 +1539,11 @@
                 <a:spcPct val="100000"/>
               </a:lnSpc>
               <a:buNone/>
-            </a:pPr>
-            <a:fld id="{6C034F33-D02B-425A-B78F-D602486F94BD}" type="slidenum">
+              <a:tabLst>
+                <a:tab pos="0" algn="l"/>
+              </a:tabLst>
+            </a:pPr>
+            <a:fld id="{7ED07285-989C-44B9-A4C7-78AFA6227171}" type="slidenum">
               <a:rPr lang="en-US" sz="1200" b="0" u="none" strike="noStrike">
                 <a:solidFill>
                   <a:schemeClr val="dk1"/>
@@ -1558,7 +1601,7 @@
         <p:spPr>
           <a:xfrm>
             <a:off x="685800" y="1143000"/>
-            <a:ext cx="5486040" cy="3085920"/>
+            <a:ext cx="5485680" cy="3085560"/>
           </a:xfrm>
           <a:prstGeom prst="rect">
             <a:avLst/>
@@ -1581,7 +1624,7 @@
         <p:spPr>
           <a:xfrm>
             <a:off x="685800" y="4400640"/>
-            <a:ext cx="5486040" cy="3600000"/>
+            <a:ext cx="5485680" cy="3599640"/>
           </a:xfrm>
           <a:prstGeom prst="rect">
             <a:avLst/>
@@ -1623,7 +1666,7 @@
         <p:spPr>
           <a:xfrm>
             <a:off x="3884760" y="8685360"/>
-            <a:ext cx="2971440" cy="458280"/>
+            <a:ext cx="2971080" cy="457920"/>
           </a:xfrm>
           <a:prstGeom prst="rect">
             <a:avLst/>
@@ -1643,6 +1686,9 @@
                 <a:spcPct val="100000"/>
               </a:lnSpc>
               <a:buNone/>
+              <a:tabLst>
+                <a:tab pos="0" algn="l"/>
+              </a:tabLst>
               <a:defRPr lang="en-US" sz="1200" b="0" u="none" strike="noStrike">
                 <a:solidFill>
                   <a:schemeClr val="dk1"/>
@@ -1660,8 +1706,11 @@
                 <a:spcPct val="100000"/>
               </a:lnSpc>
               <a:buNone/>
-            </a:pPr>
-            <a:fld id="{71F35EAB-B22A-4982-B84A-FC4728FEBA0E}" type="slidenum">
+              <a:tabLst>
+                <a:tab pos="0" algn="l"/>
+              </a:tabLst>
+            </a:pPr>
+            <a:fld id="{A4F4A93B-A531-4A0C-91EC-EBFFF6E863D4}" type="slidenum">
               <a:rPr lang="en-US" sz="1200" b="0" u="none" strike="noStrike">
                 <a:solidFill>
                   <a:schemeClr val="dk1"/>
@@ -1719,7 +1768,7 @@
         <p:spPr>
           <a:xfrm>
             <a:off x="685800" y="1143000"/>
-            <a:ext cx="5486040" cy="3085920"/>
+            <a:ext cx="5485680" cy="3085560"/>
           </a:xfrm>
           <a:prstGeom prst="rect">
             <a:avLst/>
@@ -1742,7 +1791,7 @@
         <p:spPr>
           <a:xfrm>
             <a:off x="685800" y="4400640"/>
-            <a:ext cx="5486040" cy="3600000"/>
+            <a:ext cx="5485680" cy="3599640"/>
           </a:xfrm>
           <a:prstGeom prst="rect">
             <a:avLst/>
@@ -1784,7 +1833,7 @@
         <p:spPr>
           <a:xfrm>
             <a:off x="3884760" y="8685360"/>
-            <a:ext cx="2971440" cy="458280"/>
+            <a:ext cx="2971080" cy="457920"/>
           </a:xfrm>
           <a:prstGeom prst="rect">
             <a:avLst/>
@@ -1804,6 +1853,9 @@
                 <a:spcPct val="100000"/>
               </a:lnSpc>
               <a:buNone/>
+              <a:tabLst>
+                <a:tab pos="0" algn="l"/>
+              </a:tabLst>
               <a:defRPr lang="en-US" sz="1200" b="0" u="none" strike="noStrike">
                 <a:solidFill>
                   <a:schemeClr val="dk1"/>
@@ -1821,8 +1873,11 @@
                 <a:spcPct val="100000"/>
               </a:lnSpc>
               <a:buNone/>
-            </a:pPr>
-            <a:fld id="{F888ED21-B1AA-41A0-B3F0-6DF85CD0061C}" type="slidenum">
+              <a:tabLst>
+                <a:tab pos="0" algn="l"/>
+              </a:tabLst>
+            </a:pPr>
+            <a:fld id="{C0CF29C0-7AA6-4795-B14E-8A2F3F338E28}" type="slidenum">
               <a:rPr lang="en-US" sz="1200" b="0" u="none" strike="noStrike">
                 <a:solidFill>
                   <a:schemeClr val="dk1"/>
@@ -1880,7 +1935,7 @@
         <p:spPr>
           <a:xfrm>
             <a:off x="685800" y="1143000"/>
-            <a:ext cx="5486040" cy="3085920"/>
+            <a:ext cx="5485680" cy="3085560"/>
           </a:xfrm>
           <a:prstGeom prst="rect">
             <a:avLst/>
@@ -1903,7 +1958,7 @@
         <p:spPr>
           <a:xfrm>
             <a:off x="685800" y="4400640"/>
-            <a:ext cx="5486040" cy="3600000"/>
+            <a:ext cx="5485680" cy="3599640"/>
           </a:xfrm>
           <a:prstGeom prst="rect">
             <a:avLst/>
@@ -1945,7 +2000,7 @@
         <p:spPr>
           <a:xfrm>
             <a:off x="3884760" y="8685360"/>
-            <a:ext cx="2971440" cy="458280"/>
+            <a:ext cx="2971080" cy="457920"/>
           </a:xfrm>
           <a:prstGeom prst="rect">
             <a:avLst/>
@@ -1965,6 +2020,9 @@
                 <a:spcPct val="100000"/>
               </a:lnSpc>
               <a:buNone/>
+              <a:tabLst>
+                <a:tab pos="0" algn="l"/>
+              </a:tabLst>
               <a:defRPr lang="en-US" sz="1200" b="0" u="none" strike="noStrike">
                 <a:solidFill>
                   <a:schemeClr val="dk1"/>
@@ -1982,8 +2040,11 @@
                 <a:spcPct val="100000"/>
               </a:lnSpc>
               <a:buNone/>
-            </a:pPr>
-            <a:fld id="{AA822CF2-009F-40FE-B322-1E65D95B7BC9}" type="slidenum">
+              <a:tabLst>
+                <a:tab pos="0" algn="l"/>
+              </a:tabLst>
+            </a:pPr>
+            <a:fld id="{1C677FE1-7A96-46E1-A70A-1B7A31462438}" type="slidenum">
               <a:rPr lang="en-US" sz="1200" b="0" u="none" strike="noStrike">
                 <a:solidFill>
                   <a:schemeClr val="dk1"/>
@@ -2085,40 +2146,40 @@
             <a:noAutofit/>
           </a:bodyPr>
           <a:lstStyle>
-            <a:lvl1pPr indent="0" algn="l">
+            <a:lvl1pPr indent="0" algn="ctr">
               <a:buNone/>
-              <a:defRPr lang="en-US" sz="1800" b="0" u="none" strike="noStrike">
-                <a:solidFill>
-                  <a:schemeClr val="dk1"/>
-                </a:solidFill>
-                <a:effectLst/>
-                <a:uFillTx/>
-                <a:latin typeface="Calibri"/>
+              <a:defRPr lang="en-US" sz="4400" b="0" u="none" strike="noStrike">
+                <a:solidFill>
+                  <a:srgbClr val="000000"/>
+                </a:solidFill>
+                <a:effectLst/>
+                <a:uFillTx/>
+                <a:latin typeface="Arial"/>
               </a:defRPr>
             </a:lvl1pPr>
           </a:lstStyle>
           <a:p>
-            <a:pPr indent="0" algn="l">
+            <a:pPr indent="0" algn="ctr">
               <a:buNone/>
             </a:pPr>
             <a:r>
-              <a:rPr lang="en-US" sz="1800" b="0" u="none" strike="noStrike">
-                <a:solidFill>
-                  <a:schemeClr val="dk1"/>
-                </a:solidFill>
-                <a:effectLst/>
-                <a:uFillTx/>
-                <a:latin typeface="Calibri"/>
+              <a:rPr lang="en-US" sz="4400" b="0" u="none" strike="noStrike">
+                <a:solidFill>
+                  <a:srgbClr val="000000"/>
+                </a:solidFill>
+                <a:effectLst/>
+                <a:uFillTx/>
+                <a:latin typeface="Arial"/>
               </a:rPr>
               <a:t>Click to edit the title text format</a:t>
             </a:r>
-            <a:endParaRPr lang="en-US" sz="1800" b="0" u="none" strike="noStrike">
-              <a:solidFill>
-                <a:schemeClr val="dk1"/>
-              </a:solidFill>
-              <a:effectLst/>
-              <a:uFillTx/>
-              <a:latin typeface="Calibri"/>
+            <a:endParaRPr lang="en-US" sz="4400" b="0" u="none" strike="noStrike">
+              <a:solidFill>
+                <a:srgbClr val="000000"/>
+              </a:solidFill>
+              <a:effectLst/>
+              <a:uFillTx/>
+              <a:latin typeface="Arial"/>
             </a:endParaRPr>
           </a:p>
         </p:txBody>
@@ -2163,11 +2224,11 @@
               <a:buChar char=""/>
               <a:defRPr lang="en-US" sz="3200" b="0" u="none" strike="noStrike">
                 <a:solidFill>
-                  <a:schemeClr val="dk1"/>
-                </a:solidFill>
-                <a:effectLst/>
-                <a:uFillTx/>
-                <a:latin typeface="Calibri"/>
+                  <a:srgbClr val="000000"/>
+                </a:solidFill>
+                <a:effectLst/>
+                <a:uFillTx/>
+                <a:latin typeface="Arial"/>
               </a:defRPr>
             </a:lvl1pPr>
             <a:lvl2pPr lvl="1" algn="l">
@@ -2180,13 +2241,13 @@
               <a:buSzPct val="75000"/>
               <a:buFont typeface="Symbol" charset="2"/>
               <a:buChar char=""/>
-              <a:defRPr lang="en-US" sz="2400" b="0" u="none" strike="noStrike">
-                <a:solidFill>
-                  <a:schemeClr val="dk1"/>
-                </a:solidFill>
-                <a:effectLst/>
-                <a:uFillTx/>
-                <a:latin typeface="Calibri"/>
+              <a:defRPr lang="en-US" sz="2800" b="0" u="none" strike="noStrike">
+                <a:solidFill>
+                  <a:srgbClr val="000000"/>
+                </a:solidFill>
+                <a:effectLst/>
+                <a:uFillTx/>
+                <a:latin typeface="Arial"/>
               </a:defRPr>
             </a:lvl2pPr>
             <a:lvl3pPr lvl="2" algn="l">
@@ -2199,13 +2260,13 @@
               <a:buSzPct val="45000"/>
               <a:buFont typeface="Wingdings" charset="2"/>
               <a:buChar char=""/>
-              <a:defRPr lang="en-US" sz="2000" b="0" u="none" strike="noStrike">
-                <a:solidFill>
-                  <a:schemeClr val="dk1"/>
-                </a:solidFill>
-                <a:effectLst/>
-                <a:uFillTx/>
-                <a:latin typeface="Calibri"/>
+              <a:defRPr lang="en-US" sz="2400" b="0" u="none" strike="noStrike">
+                <a:solidFill>
+                  <a:srgbClr val="000000"/>
+                </a:solidFill>
+                <a:effectLst/>
+                <a:uFillTx/>
+                <a:latin typeface="Arial"/>
               </a:defRPr>
             </a:lvl3pPr>
             <a:lvl4pPr lvl="3" algn="l">
@@ -2220,11 +2281,11 @@
               <a:buChar char=""/>
               <a:defRPr lang="en-US" sz="2000" b="0" u="none" strike="noStrike">
                 <a:solidFill>
-                  <a:schemeClr val="dk1"/>
-                </a:solidFill>
-                <a:effectLst/>
-                <a:uFillTx/>
-                <a:latin typeface="Calibri"/>
+                  <a:srgbClr val="000000"/>
+                </a:solidFill>
+                <a:effectLst/>
+                <a:uFillTx/>
+                <a:latin typeface="Arial"/>
               </a:defRPr>
             </a:lvl4pPr>
             <a:lvl5pPr lvl="4" algn="l">
@@ -2239,11 +2300,11 @@
               <a:buChar char=""/>
               <a:defRPr lang="en-US" sz="2000" b="0" u="none" strike="noStrike">
                 <a:solidFill>
-                  <a:schemeClr val="dk1"/>
-                </a:solidFill>
-                <a:effectLst/>
-                <a:uFillTx/>
-                <a:latin typeface="Calibri"/>
+                  <a:srgbClr val="000000"/>
+                </a:solidFill>
+                <a:effectLst/>
+                <a:uFillTx/>
+                <a:latin typeface="Arial"/>
               </a:defRPr>
             </a:lvl5pPr>
             <a:lvl6pPr lvl="5" algn="l">
@@ -2258,11 +2319,11 @@
               <a:buChar char=""/>
               <a:defRPr lang="en-US" sz="2000" b="0" u="none" strike="noStrike">
                 <a:solidFill>
-                  <a:schemeClr val="dk1"/>
-                </a:solidFill>
-                <a:effectLst/>
-                <a:uFillTx/>
-                <a:latin typeface="Calibri"/>
+                  <a:srgbClr val="000000"/>
+                </a:solidFill>
+                <a:effectLst/>
+                <a:uFillTx/>
+                <a:latin typeface="Arial"/>
               </a:defRPr>
             </a:lvl6pPr>
             <a:lvl7pPr lvl="6" algn="l">
@@ -2277,11 +2338,11 @@
               <a:buChar char=""/>
               <a:defRPr lang="en-US" sz="2000" b="0" u="none" strike="noStrike">
                 <a:solidFill>
-                  <a:schemeClr val="dk1"/>
-                </a:solidFill>
-                <a:effectLst/>
-                <a:uFillTx/>
-                <a:latin typeface="Calibri"/>
+                  <a:srgbClr val="000000"/>
+                </a:solidFill>
+                <a:effectLst/>
+                <a:uFillTx/>
+                <a:latin typeface="Arial"/>
               </a:defRPr>
             </a:lvl7pPr>
           </a:lstStyle>
@@ -2300,21 +2361,21 @@
             <a:r>
               <a:rPr lang="en-US" sz="3200" b="0" u="none" strike="noStrike">
                 <a:solidFill>
-                  <a:schemeClr val="dk1"/>
-                </a:solidFill>
-                <a:effectLst/>
-                <a:uFillTx/>
-                <a:latin typeface="Calibri"/>
+                  <a:srgbClr val="000000"/>
+                </a:solidFill>
+                <a:effectLst/>
+                <a:uFillTx/>
+                <a:latin typeface="Arial"/>
               </a:rPr>
               <a:t>Click to edit the outline text format</a:t>
             </a:r>
             <a:endParaRPr lang="en-US" sz="3200" b="0" u="none" strike="noStrike">
               <a:solidFill>
-                <a:schemeClr val="dk1"/>
-              </a:solidFill>
-              <a:effectLst/>
-              <a:uFillTx/>
-              <a:latin typeface="Calibri"/>
+                <a:srgbClr val="000000"/>
+              </a:solidFill>
+              <a:effectLst/>
+              <a:uFillTx/>
+              <a:latin typeface="Arial"/>
             </a:endParaRPr>
           </a:p>
           <a:p>
@@ -2330,23 +2391,23 @@
               <a:buChar char=""/>
             </a:pPr>
             <a:r>
-              <a:rPr lang="en-US" sz="2400" b="0" u="none" strike="noStrike">
-                <a:solidFill>
-                  <a:schemeClr val="dk1"/>
-                </a:solidFill>
-                <a:effectLst/>
-                <a:uFillTx/>
-                <a:latin typeface="Calibri"/>
+              <a:rPr lang="en-US" sz="2800" b="0" u="none" strike="noStrike">
+                <a:solidFill>
+                  <a:srgbClr val="000000"/>
+                </a:solidFill>
+                <a:effectLst/>
+                <a:uFillTx/>
+                <a:latin typeface="Arial"/>
               </a:rPr>
               <a:t>Second Outline Level</a:t>
             </a:r>
-            <a:endParaRPr lang="en-US" sz="2400" b="0" u="none" strike="noStrike">
-              <a:solidFill>
-                <a:schemeClr val="dk1"/>
-              </a:solidFill>
-              <a:effectLst/>
-              <a:uFillTx/>
-              <a:latin typeface="Calibri"/>
+            <a:endParaRPr lang="en-US" sz="2800" b="0" u="none" strike="noStrike">
+              <a:solidFill>
+                <a:srgbClr val="000000"/>
+              </a:solidFill>
+              <a:effectLst/>
+              <a:uFillTx/>
+              <a:latin typeface="Arial"/>
             </a:endParaRPr>
           </a:p>
           <a:p>
@@ -2362,23 +2423,23 @@
               <a:buChar char=""/>
             </a:pPr>
             <a:r>
-              <a:rPr lang="en-US" sz="2000" b="0" u="none" strike="noStrike">
-                <a:solidFill>
-                  <a:schemeClr val="dk1"/>
-                </a:solidFill>
-                <a:effectLst/>
-                <a:uFillTx/>
-                <a:latin typeface="Calibri"/>
+              <a:rPr lang="en-US" sz="2400" b="0" u="none" strike="noStrike">
+                <a:solidFill>
+                  <a:srgbClr val="000000"/>
+                </a:solidFill>
+                <a:effectLst/>
+                <a:uFillTx/>
+                <a:latin typeface="Arial"/>
               </a:rPr>
               <a:t>Third Outline Level</a:t>
             </a:r>
-            <a:endParaRPr lang="en-US" sz="2000" b="0" u="none" strike="noStrike">
-              <a:solidFill>
-                <a:schemeClr val="dk1"/>
-              </a:solidFill>
-              <a:effectLst/>
-              <a:uFillTx/>
-              <a:latin typeface="Calibri"/>
+            <a:endParaRPr lang="en-US" sz="2400" b="0" u="none" strike="noStrike">
+              <a:solidFill>
+                <a:srgbClr val="000000"/>
+              </a:solidFill>
+              <a:effectLst/>
+              <a:uFillTx/>
+              <a:latin typeface="Arial"/>
             </a:endParaRPr>
           </a:p>
           <a:p>
@@ -2396,21 +2457,21 @@
             <a:r>
               <a:rPr lang="en-US" sz="2000" b="0" u="none" strike="noStrike">
                 <a:solidFill>
-                  <a:schemeClr val="dk1"/>
-                </a:solidFill>
-                <a:effectLst/>
-                <a:uFillTx/>
-                <a:latin typeface="Calibri"/>
+                  <a:srgbClr val="000000"/>
+                </a:solidFill>
+                <a:effectLst/>
+                <a:uFillTx/>
+                <a:latin typeface="Arial"/>
               </a:rPr>
               <a:t>Fourth Outline Level</a:t>
             </a:r>
             <a:endParaRPr lang="en-US" sz="2000" b="0" u="none" strike="noStrike">
               <a:solidFill>
-                <a:schemeClr val="dk1"/>
-              </a:solidFill>
-              <a:effectLst/>
-              <a:uFillTx/>
-              <a:latin typeface="Calibri"/>
+                <a:srgbClr val="000000"/>
+              </a:solidFill>
+              <a:effectLst/>
+              <a:uFillTx/>
+              <a:latin typeface="Arial"/>
             </a:endParaRPr>
           </a:p>
           <a:p>
@@ -2428,21 +2489,21 @@
             <a:r>
               <a:rPr lang="en-US" sz="2000" b="0" u="none" strike="noStrike">
                 <a:solidFill>
-                  <a:schemeClr val="dk1"/>
-                </a:solidFill>
-                <a:effectLst/>
-                <a:uFillTx/>
-                <a:latin typeface="Calibri"/>
+                  <a:srgbClr val="000000"/>
+                </a:solidFill>
+                <a:effectLst/>
+                <a:uFillTx/>
+                <a:latin typeface="Arial"/>
               </a:rPr>
               <a:t>Fifth Outline Level</a:t>
             </a:r>
             <a:endParaRPr lang="en-US" sz="2000" b="0" u="none" strike="noStrike">
               <a:solidFill>
-                <a:schemeClr val="dk1"/>
-              </a:solidFill>
-              <a:effectLst/>
-              <a:uFillTx/>
-              <a:latin typeface="Calibri"/>
+                <a:srgbClr val="000000"/>
+              </a:solidFill>
+              <a:effectLst/>
+              <a:uFillTx/>
+              <a:latin typeface="Arial"/>
             </a:endParaRPr>
           </a:p>
           <a:p>
@@ -2460,21 +2521,21 @@
             <a:r>
               <a:rPr lang="en-US" sz="2000" b="0" u="none" strike="noStrike">
                 <a:solidFill>
-                  <a:schemeClr val="dk1"/>
-                </a:solidFill>
-                <a:effectLst/>
-                <a:uFillTx/>
-                <a:latin typeface="Calibri"/>
+                  <a:srgbClr val="000000"/>
+                </a:solidFill>
+                <a:effectLst/>
+                <a:uFillTx/>
+                <a:latin typeface="Arial"/>
               </a:rPr>
               <a:t>Sixth Outline Level</a:t>
             </a:r>
             <a:endParaRPr lang="en-US" sz="2000" b="0" u="none" strike="noStrike">
               <a:solidFill>
-                <a:schemeClr val="dk1"/>
-              </a:solidFill>
-              <a:effectLst/>
-              <a:uFillTx/>
-              <a:latin typeface="Calibri"/>
+                <a:srgbClr val="000000"/>
+              </a:solidFill>
+              <a:effectLst/>
+              <a:uFillTx/>
+              <a:latin typeface="Arial"/>
             </a:endParaRPr>
           </a:p>
           <a:p>
@@ -2492,21 +2553,21 @@
             <a:r>
               <a:rPr lang="en-US" sz="2000" b="0" u="none" strike="noStrike">
                 <a:solidFill>
-                  <a:schemeClr val="dk1"/>
-                </a:solidFill>
-                <a:effectLst/>
-                <a:uFillTx/>
-                <a:latin typeface="Calibri"/>
+                  <a:srgbClr val="000000"/>
+                </a:solidFill>
+                <a:effectLst/>
+                <a:uFillTx/>
+                <a:latin typeface="Arial"/>
               </a:rPr>
               <a:t>Seventh Outline Level</a:t>
             </a:r>
             <a:endParaRPr lang="en-US" sz="2000" b="0" u="none" strike="noStrike">
               <a:solidFill>
-                <a:schemeClr val="dk1"/>
-              </a:solidFill>
-              <a:effectLst/>
-              <a:uFillTx/>
-              <a:latin typeface="Calibri"/>
+                <a:srgbClr val="000000"/>
+              </a:solidFill>
+              <a:effectLst/>
+              <a:uFillTx/>
+              <a:latin typeface="Arial"/>
             </a:endParaRPr>
           </a:p>
         </p:txBody>
@@ -2553,7 +2614,7 @@
         <p:spPr>
           <a:xfrm>
             <a:off x="0" y="0"/>
-            <a:ext cx="9143640" cy="5143320"/>
+            <a:ext cx="9143280" cy="5142960"/>
           </a:xfrm>
           <a:prstGeom prst="rect">
             <a:avLst/>
@@ -2596,7 +2657,7 @@
         <p:spPr>
           <a:xfrm>
             <a:off x="0" y="2011680"/>
-            <a:ext cx="9143640" cy="72720"/>
+            <a:ext cx="9143280" cy="72360"/>
           </a:xfrm>
           <a:prstGeom prst="rect">
             <a:avLst/>
@@ -2639,7 +2700,7 @@
         <p:spPr>
           <a:xfrm>
             <a:off x="457200" y="457200"/>
-            <a:ext cx="8229240" cy="731160"/>
+            <a:ext cx="8228880" cy="730800"/>
           </a:xfrm>
           <a:prstGeom prst="rect">
             <a:avLst/>
@@ -2700,7 +2761,7 @@
         <p:spPr>
           <a:xfrm>
             <a:off x="457200" y="1143000"/>
-            <a:ext cx="8229240" cy="731160"/>
+            <a:ext cx="8228880" cy="730800"/>
           </a:xfrm>
           <a:prstGeom prst="rect">
             <a:avLst/>
@@ -2761,7 +2822,7 @@
         <p:spPr>
           <a:xfrm>
             <a:off x="457200" y="2240280"/>
-            <a:ext cx="8229240" cy="456840"/>
+            <a:ext cx="8228880" cy="456480"/>
           </a:xfrm>
           <a:prstGeom prst="rect">
             <a:avLst/>
@@ -2822,7 +2883,7 @@
         <p:spPr>
           <a:xfrm>
             <a:off x="457200" y="2697480"/>
-            <a:ext cx="8229240" cy="365400"/>
+            <a:ext cx="8228880" cy="365040"/>
           </a:xfrm>
           <a:prstGeom prst="rect">
             <a:avLst/>
@@ -2883,7 +2944,7 @@
         <p:spPr>
           <a:xfrm>
             <a:off x="2286000" y="3291840"/>
-            <a:ext cx="4571640" cy="1279800"/>
+            <a:ext cx="4571280" cy="1279440"/>
           </a:xfrm>
           <a:prstGeom prst="rect">
             <a:avLst/>
@@ -2929,7 +2990,7 @@
         <p:spPr>
           <a:xfrm>
             <a:off x="2468880" y="3401640"/>
-            <a:ext cx="4205880" cy="1005480"/>
+            <a:ext cx="4205520" cy="1005120"/>
           </a:xfrm>
           <a:prstGeom prst="rect">
             <a:avLst/>
@@ -2950,6 +3011,11 @@
             <a:noAutofit/>
           </a:bodyPr>
           <a:p>
+            <a:pPr>
+              <a:lnSpc>
+                <a:spcPct val="100000"/>
+              </a:lnSpc>
+            </a:pPr>
             <a:r>
               <a:rPr lang="en-US" sz="1300" b="1" u="none" strike="noStrike">
                 <a:solidFill>
@@ -2984,6 +3050,11 @@
             </a:endParaRPr>
           </a:p>
           <a:p>
+            <a:pPr>
+              <a:lnSpc>
+                <a:spcPct val="100000"/>
+              </a:lnSpc>
+            </a:pPr>
             <a:r>
               <a:rPr lang="en-US" sz="1300" b="1" u="none" strike="noStrike">
                 <a:solidFill>
@@ -3107,7 +3178,7 @@
         <p:spPr>
           <a:xfrm>
             <a:off x="0" y="0"/>
-            <a:ext cx="9143640" cy="685440"/>
+            <a:ext cx="9143280" cy="685080"/>
           </a:xfrm>
           <a:prstGeom prst="rect">
             <a:avLst/>
@@ -3150,7 +3221,7 @@
         <p:spPr>
           <a:xfrm>
             <a:off x="274320" y="73080"/>
-            <a:ext cx="8595000" cy="548280"/>
+            <a:ext cx="8594640" cy="547920"/>
           </a:xfrm>
           <a:prstGeom prst="rect">
             <a:avLst/>
@@ -3211,7 +3282,7 @@
         <p:spPr>
           <a:xfrm>
             <a:off x="274320" y="822960"/>
-            <a:ext cx="4114440" cy="1234080"/>
+            <a:ext cx="4114080" cy="1233720"/>
           </a:xfrm>
           <a:prstGeom prst="rect">
             <a:avLst/>
@@ -3257,7 +3328,7 @@
         <p:spPr>
           <a:xfrm>
             <a:off x="411480" y="914400"/>
-            <a:ext cx="3840120" cy="319680"/>
+            <a:ext cx="3839760" cy="319320"/>
           </a:xfrm>
           <a:prstGeom prst="rect">
             <a:avLst/>
@@ -3318,7 +3389,7 @@
         <p:spPr>
           <a:xfrm>
             <a:off x="411480" y="1280160"/>
-            <a:ext cx="3840120" cy="658080"/>
+            <a:ext cx="3839760" cy="657720"/>
           </a:xfrm>
           <a:prstGeom prst="rect">
             <a:avLst/>
@@ -3379,7 +3450,7 @@
         <p:spPr>
           <a:xfrm>
             <a:off x="4709160" y="822960"/>
-            <a:ext cx="4114440" cy="1234080"/>
+            <a:ext cx="4114080" cy="1233720"/>
           </a:xfrm>
           <a:prstGeom prst="rect">
             <a:avLst/>
@@ -3425,7 +3496,7 @@
         <p:spPr>
           <a:xfrm>
             <a:off x="4846320" y="914400"/>
-            <a:ext cx="3840120" cy="319680"/>
+            <a:ext cx="3839760" cy="319320"/>
           </a:xfrm>
           <a:prstGeom prst="rect">
             <a:avLst/>
@@ -3486,7 +3557,7 @@
         <p:spPr>
           <a:xfrm>
             <a:off x="4846320" y="1280160"/>
-            <a:ext cx="3840120" cy="658080"/>
+            <a:ext cx="3839760" cy="657720"/>
           </a:xfrm>
           <a:prstGeom prst="rect">
             <a:avLst/>
@@ -3547,7 +3618,7 @@
         <p:spPr>
           <a:xfrm>
             <a:off x="274320" y="2194560"/>
-            <a:ext cx="4114440" cy="1234080"/>
+            <a:ext cx="4114080" cy="1233720"/>
           </a:xfrm>
           <a:prstGeom prst="rect">
             <a:avLst/>
@@ -3593,7 +3664,7 @@
         <p:spPr>
           <a:xfrm>
             <a:off x="411480" y="2286000"/>
-            <a:ext cx="3840120" cy="319680"/>
+            <a:ext cx="3839760" cy="319320"/>
           </a:xfrm>
           <a:prstGeom prst="rect">
             <a:avLst/>
@@ -3654,7 +3725,7 @@
         <p:spPr>
           <a:xfrm>
             <a:off x="411480" y="2651760"/>
-            <a:ext cx="3840120" cy="658080"/>
+            <a:ext cx="3839760" cy="657720"/>
           </a:xfrm>
           <a:prstGeom prst="rect">
             <a:avLst/>
@@ -3715,7 +3786,7 @@
         <p:spPr>
           <a:xfrm>
             <a:off x="4709160" y="2194560"/>
-            <a:ext cx="4114440" cy="1234080"/>
+            <a:ext cx="4114080" cy="1233720"/>
           </a:xfrm>
           <a:prstGeom prst="rect">
             <a:avLst/>
@@ -3761,7 +3832,7 @@
         <p:spPr>
           <a:xfrm>
             <a:off x="4846320" y="2286000"/>
-            <a:ext cx="3840120" cy="319680"/>
+            <a:ext cx="3839760" cy="319320"/>
           </a:xfrm>
           <a:prstGeom prst="rect">
             <a:avLst/>
@@ -3822,7 +3893,7 @@
         <p:spPr>
           <a:xfrm>
             <a:off x="4846320" y="2651760"/>
-            <a:ext cx="3840120" cy="658080"/>
+            <a:ext cx="3839760" cy="657720"/>
           </a:xfrm>
           <a:prstGeom prst="rect">
             <a:avLst/>
@@ -3883,7 +3954,7 @@
         <p:spPr>
           <a:xfrm>
             <a:off x="274320" y="3566160"/>
-            <a:ext cx="4114440" cy="1234080"/>
+            <a:ext cx="4114080" cy="1233720"/>
           </a:xfrm>
           <a:prstGeom prst="rect">
             <a:avLst/>
@@ -3929,7 +4000,7 @@
         <p:spPr>
           <a:xfrm>
             <a:off x="411480" y="3657600"/>
-            <a:ext cx="3840120" cy="319680"/>
+            <a:ext cx="3839760" cy="319320"/>
           </a:xfrm>
           <a:prstGeom prst="rect">
             <a:avLst/>
@@ -3990,7 +4061,7 @@
         <p:spPr>
           <a:xfrm>
             <a:off x="411480" y="4023360"/>
-            <a:ext cx="3840120" cy="658080"/>
+            <a:ext cx="3839760" cy="657720"/>
           </a:xfrm>
           <a:prstGeom prst="rect">
             <a:avLst/>
@@ -4051,7 +4122,7 @@
         <p:spPr>
           <a:xfrm>
             <a:off x="4709160" y="3566160"/>
-            <a:ext cx="4114440" cy="1234080"/>
+            <a:ext cx="4114080" cy="1233720"/>
           </a:xfrm>
           <a:prstGeom prst="rect">
             <a:avLst/>
@@ -4097,7 +4168,7 @@
         <p:spPr>
           <a:xfrm>
             <a:off x="4846320" y="3657600"/>
-            <a:ext cx="3840120" cy="319680"/>
+            <a:ext cx="3839760" cy="319320"/>
           </a:xfrm>
           <a:prstGeom prst="rect">
             <a:avLst/>
@@ -4158,7 +4229,7 @@
         <p:spPr>
           <a:xfrm>
             <a:off x="4846320" y="4023360"/>
-            <a:ext cx="3840120" cy="658080"/>
+            <a:ext cx="3839760" cy="657720"/>
           </a:xfrm>
           <a:prstGeom prst="rect">
             <a:avLst/>
@@ -4256,7 +4327,7 @@
         <p:spPr>
           <a:xfrm>
             <a:off x="0" y="0"/>
-            <a:ext cx="9143640" cy="685440"/>
+            <a:ext cx="9143280" cy="685080"/>
           </a:xfrm>
           <a:prstGeom prst="rect">
             <a:avLst/>
@@ -4299,7 +4370,7 @@
         <p:spPr>
           <a:xfrm>
             <a:off x="274320" y="73080"/>
-            <a:ext cx="8595000" cy="548280"/>
+            <a:ext cx="8594640" cy="547920"/>
           </a:xfrm>
           <a:prstGeom prst="rect">
             <a:avLst/>
@@ -4360,7 +4431,7 @@
         <p:spPr>
           <a:xfrm>
             <a:off x="274320" y="777240"/>
-            <a:ext cx="5028840" cy="2102760"/>
+            <a:ext cx="5028480" cy="2102400"/>
           </a:xfrm>
           <a:prstGeom prst="rect">
             <a:avLst/>
@@ -4406,7 +4477,7 @@
         <p:spPr>
           <a:xfrm>
             <a:off x="365760" y="850320"/>
-            <a:ext cx="4845960" cy="1956600"/>
+            <a:ext cx="4845600" cy="1956240"/>
           </a:xfrm>
           <a:prstGeom prst="rect">
             <a:avLst/>
@@ -4671,7 +4742,7 @@
         <p:spPr>
           <a:xfrm>
             <a:off x="5486400" y="777240"/>
-            <a:ext cx="3382920" cy="2102760"/>
+            <a:ext cx="3382560" cy="2102400"/>
           </a:xfrm>
           <a:prstGeom prst="rect">
             <a:avLst/>
@@ -4717,7 +4788,7 @@
         <p:spPr>
           <a:xfrm>
             <a:off x="5577840" y="822960"/>
-            <a:ext cx="3200040" cy="273960"/>
+            <a:ext cx="3199680" cy="273600"/>
           </a:xfrm>
           <a:prstGeom prst="rect">
             <a:avLst/>
@@ -4778,7 +4849,7 @@
         <p:spPr>
           <a:xfrm>
             <a:off x="5577840" y="1143000"/>
-            <a:ext cx="3200040" cy="1599840"/>
+            <a:ext cx="3199680" cy="1599480"/>
           </a:xfrm>
           <a:prstGeom prst="rect">
             <a:avLst/>
@@ -4959,7 +5030,7 @@
         <p:spPr>
           <a:xfrm>
             <a:off x="274320" y="3017520"/>
-            <a:ext cx="4205880" cy="1645560"/>
+            <a:ext cx="4205520" cy="1645200"/>
           </a:xfrm>
           <a:prstGeom prst="rect">
             <a:avLst/>
@@ -5005,7 +5076,7 @@
         <p:spPr>
           <a:xfrm>
             <a:off x="411480" y="3090600"/>
-            <a:ext cx="3931560" cy="319680"/>
+            <a:ext cx="3931200" cy="319320"/>
           </a:xfrm>
           <a:prstGeom prst="rect">
             <a:avLst/>
@@ -5066,7 +5137,7 @@
         <p:spPr>
           <a:xfrm>
             <a:off x="411480" y="3429000"/>
-            <a:ext cx="3931560" cy="1096920"/>
+            <a:ext cx="3931200" cy="1096560"/>
           </a:xfrm>
           <a:prstGeom prst="rect">
             <a:avLst/>
@@ -5217,7 +5288,7 @@
         <p:spPr>
           <a:xfrm>
             <a:off x="4846320" y="3017520"/>
-            <a:ext cx="4205880" cy="1645560"/>
+            <a:ext cx="4205520" cy="1645200"/>
           </a:xfrm>
           <a:prstGeom prst="rect">
             <a:avLst/>
@@ -5263,7 +5334,7 @@
         <p:spPr>
           <a:xfrm>
             <a:off x="4983480" y="3090600"/>
-            <a:ext cx="3931560" cy="319680"/>
+            <a:ext cx="3931200" cy="319320"/>
           </a:xfrm>
           <a:prstGeom prst="rect">
             <a:avLst/>
@@ -5324,7 +5395,7 @@
         <p:spPr>
           <a:xfrm>
             <a:off x="4983480" y="3429000"/>
-            <a:ext cx="3931560" cy="1096920"/>
+            <a:ext cx="3931200" cy="1096560"/>
           </a:xfrm>
           <a:prstGeom prst="rect">
             <a:avLst/>
@@ -5452,7 +5523,7 @@
         <p:spPr>
           <a:xfrm>
             <a:off x="0" y="0"/>
-            <a:ext cx="9143640" cy="685440"/>
+            <a:ext cx="9143280" cy="685080"/>
           </a:xfrm>
           <a:prstGeom prst="rect">
             <a:avLst/>
@@ -5495,7 +5566,7 @@
         <p:spPr>
           <a:xfrm>
             <a:off x="274320" y="73080"/>
-            <a:ext cx="8595000" cy="548280"/>
+            <a:ext cx="8594640" cy="547920"/>
           </a:xfrm>
           <a:prstGeom prst="rect">
             <a:avLst/>
@@ -5556,7 +5627,7 @@
         <p:spPr>
           <a:xfrm>
             <a:off x="274320" y="777240"/>
-            <a:ext cx="8595000" cy="1554120"/>
+            <a:ext cx="8594640" cy="1553760"/>
           </a:xfrm>
           <a:prstGeom prst="rect">
             <a:avLst/>
@@ -5602,7 +5673,7 @@
         <p:spPr>
           <a:xfrm>
             <a:off x="365760" y="850320"/>
-            <a:ext cx="8412120" cy="1407960"/>
+            <a:ext cx="8411760" cy="1407600"/>
           </a:xfrm>
           <a:prstGeom prst="rect">
             <a:avLst/>
@@ -5783,7 +5854,7 @@
         <p:spPr>
           <a:xfrm>
             <a:off x="274320" y="2514600"/>
-            <a:ext cx="4114440" cy="1234080"/>
+            <a:ext cx="4114080" cy="1233720"/>
           </a:xfrm>
           <a:prstGeom prst="rect">
             <a:avLst/>
@@ -5829,7 +5900,7 @@
         <p:spPr>
           <a:xfrm>
             <a:off x="411480" y="2606040"/>
-            <a:ext cx="3840120" cy="273960"/>
+            <a:ext cx="3839760" cy="273600"/>
           </a:xfrm>
           <a:prstGeom prst="rect">
             <a:avLst/>
@@ -5890,7 +5961,7 @@
         <p:spPr>
           <a:xfrm>
             <a:off x="411480" y="2926080"/>
-            <a:ext cx="3840120" cy="731160"/>
+            <a:ext cx="3839760" cy="730800"/>
           </a:xfrm>
           <a:prstGeom prst="rect">
             <a:avLst/>
@@ -6011,7 +6082,7 @@
         <p:spPr>
           <a:xfrm>
             <a:off x="4709160" y="2514600"/>
-            <a:ext cx="4114440" cy="1234080"/>
+            <a:ext cx="4114080" cy="1233720"/>
           </a:xfrm>
           <a:prstGeom prst="rect">
             <a:avLst/>
@@ -6057,7 +6128,7 @@
         <p:spPr>
           <a:xfrm>
             <a:off x="4846320" y="2606040"/>
-            <a:ext cx="3840120" cy="273960"/>
+            <a:ext cx="3839760" cy="273600"/>
           </a:xfrm>
           <a:prstGeom prst="rect">
             <a:avLst/>
@@ -6118,7 +6189,7 @@
         <p:spPr>
           <a:xfrm>
             <a:off x="4846320" y="2926080"/>
-            <a:ext cx="3840120" cy="731160"/>
+            <a:ext cx="3839760" cy="730800"/>
           </a:xfrm>
           <a:prstGeom prst="rect">
             <a:avLst/>
@@ -6209,7 +6280,7 @@
         <p:spPr>
           <a:xfrm>
             <a:off x="274320" y="3886200"/>
-            <a:ext cx="4114440" cy="1234080"/>
+            <a:ext cx="4114080" cy="1233720"/>
           </a:xfrm>
           <a:prstGeom prst="rect">
             <a:avLst/>
@@ -6255,7 +6326,7 @@
         <p:spPr>
           <a:xfrm>
             <a:off x="411480" y="3977640"/>
-            <a:ext cx="3840120" cy="273960"/>
+            <a:ext cx="3839760" cy="273600"/>
           </a:xfrm>
           <a:prstGeom prst="rect">
             <a:avLst/>
@@ -6316,7 +6387,7 @@
         <p:spPr>
           <a:xfrm>
             <a:off x="411480" y="4297680"/>
-            <a:ext cx="3840120" cy="731160"/>
+            <a:ext cx="3839760" cy="730800"/>
           </a:xfrm>
           <a:prstGeom prst="rect">
             <a:avLst/>
@@ -6407,7 +6478,7 @@
         <p:spPr>
           <a:xfrm>
             <a:off x="4709160" y="3886200"/>
-            <a:ext cx="4114440" cy="1234080"/>
+            <a:ext cx="4114080" cy="1233720"/>
           </a:xfrm>
           <a:prstGeom prst="rect">
             <a:avLst/>
@@ -6453,7 +6524,7 @@
         <p:spPr>
           <a:xfrm>
             <a:off x="4846320" y="3977640"/>
-            <a:ext cx="3840120" cy="273960"/>
+            <a:ext cx="3839760" cy="273600"/>
           </a:xfrm>
           <a:prstGeom prst="rect">
             <a:avLst/>
@@ -6514,7 +6585,7 @@
         <p:spPr>
           <a:xfrm>
             <a:off x="4846320" y="4297680"/>
-            <a:ext cx="3840120" cy="731160"/>
+            <a:ext cx="3839760" cy="730800"/>
           </a:xfrm>
           <a:prstGeom prst="rect">
             <a:avLst/>
@@ -6642,7 +6713,7 @@
         <p:spPr>
           <a:xfrm>
             <a:off x="0" y="0"/>
-            <a:ext cx="9143640" cy="685440"/>
+            <a:ext cx="9143280" cy="685080"/>
           </a:xfrm>
           <a:prstGeom prst="rect">
             <a:avLst/>
@@ -6685,7 +6756,7 @@
         <p:spPr>
           <a:xfrm>
             <a:off x="274320" y="73080"/>
-            <a:ext cx="8595000" cy="548280"/>
+            <a:ext cx="8594640" cy="547920"/>
           </a:xfrm>
           <a:prstGeom prst="rect">
             <a:avLst/>
@@ -6746,7 +6817,7 @@
         <p:spPr>
           <a:xfrm>
             <a:off x="274320" y="777240"/>
-            <a:ext cx="4754520" cy="2285640"/>
+            <a:ext cx="4754160" cy="2285280"/>
           </a:xfrm>
           <a:prstGeom prst="rect">
             <a:avLst/>
@@ -6792,7 +6863,7 @@
         <p:spPr>
           <a:xfrm>
             <a:off x="365760" y="850320"/>
-            <a:ext cx="4571640" cy="2139480"/>
+            <a:ext cx="4571280" cy="2139120"/>
           </a:xfrm>
           <a:prstGeom prst="rect">
             <a:avLst/>
@@ -7069,7 +7140,7 @@
         <p:spPr>
           <a:xfrm>
             <a:off x="5212080" y="822960"/>
-            <a:ext cx="1737000" cy="959760"/>
+            <a:ext cx="1736640" cy="959400"/>
           </a:xfrm>
           <a:prstGeom prst="rect">
             <a:avLst/>
@@ -7115,7 +7186,7 @@
         <p:spPr>
           <a:xfrm>
             <a:off x="5303520" y="896040"/>
-            <a:ext cx="1554120" cy="319680"/>
+            <a:ext cx="1553760" cy="319320"/>
           </a:xfrm>
           <a:prstGeom prst="rect">
             <a:avLst/>
@@ -7176,7 +7247,7 @@
         <p:spPr>
           <a:xfrm>
             <a:off x="5303520" y="1261800"/>
-            <a:ext cx="1554120" cy="411120"/>
+            <a:ext cx="1553760" cy="410760"/>
           </a:xfrm>
           <a:prstGeom prst="rect">
             <a:avLst/>
@@ -7237,7 +7308,7 @@
         <p:spPr>
           <a:xfrm>
             <a:off x="7086600" y="822960"/>
-            <a:ext cx="1737000" cy="959760"/>
+            <a:ext cx="1736640" cy="959400"/>
           </a:xfrm>
           <a:prstGeom prst="rect">
             <a:avLst/>
@@ -7283,7 +7354,7 @@
         <p:spPr>
           <a:xfrm>
             <a:off x="7178040" y="896040"/>
-            <a:ext cx="1554120" cy="319680"/>
+            <a:ext cx="1553760" cy="319320"/>
           </a:xfrm>
           <a:prstGeom prst="rect">
             <a:avLst/>
@@ -7344,7 +7415,7 @@
         <p:spPr>
           <a:xfrm>
             <a:off x="7178040" y="1261800"/>
-            <a:ext cx="1554120" cy="411120"/>
+            <a:ext cx="1553760" cy="410760"/>
           </a:xfrm>
           <a:prstGeom prst="rect">
             <a:avLst/>
@@ -7405,7 +7476,7 @@
         <p:spPr>
           <a:xfrm>
             <a:off x="5212080" y="1920240"/>
-            <a:ext cx="1737000" cy="959760"/>
+            <a:ext cx="1736640" cy="959400"/>
           </a:xfrm>
           <a:prstGeom prst="rect">
             <a:avLst/>
@@ -7451,7 +7522,7 @@
         <p:spPr>
           <a:xfrm>
             <a:off x="5303520" y="1993320"/>
-            <a:ext cx="1554120" cy="319680"/>
+            <a:ext cx="1553760" cy="319320"/>
           </a:xfrm>
           <a:prstGeom prst="rect">
             <a:avLst/>
@@ -7512,7 +7583,7 @@
         <p:spPr>
           <a:xfrm>
             <a:off x="5303520" y="2359080"/>
-            <a:ext cx="1554120" cy="411120"/>
+            <a:ext cx="1553760" cy="410760"/>
           </a:xfrm>
           <a:prstGeom prst="rect">
             <a:avLst/>
@@ -7573,7 +7644,7 @@
         <p:spPr>
           <a:xfrm>
             <a:off x="7086600" y="1920240"/>
-            <a:ext cx="1737000" cy="959760"/>
+            <a:ext cx="1736640" cy="959400"/>
           </a:xfrm>
           <a:prstGeom prst="rect">
             <a:avLst/>
@@ -7619,7 +7690,7 @@
         <p:spPr>
           <a:xfrm>
             <a:off x="7178040" y="1993320"/>
-            <a:ext cx="1554120" cy="319680"/>
+            <a:ext cx="1553760" cy="319320"/>
           </a:xfrm>
           <a:prstGeom prst="rect">
             <a:avLst/>
@@ -7680,7 +7751,7 @@
         <p:spPr>
           <a:xfrm>
             <a:off x="7178040" y="2359080"/>
-            <a:ext cx="1554120" cy="411120"/>
+            <a:ext cx="1553760" cy="410760"/>
           </a:xfrm>
           <a:prstGeom prst="rect">
             <a:avLst/>
@@ -7741,7 +7812,7 @@
         <p:spPr>
           <a:xfrm>
             <a:off x="5212080" y="3063240"/>
-            <a:ext cx="3657240" cy="411120"/>
+            <a:ext cx="3656880" cy="410760"/>
           </a:xfrm>
           <a:prstGeom prst="rect">
             <a:avLst/>
@@ -7802,7 +7873,7 @@
         <p:spPr>
           <a:xfrm>
             <a:off x="274320" y="3200400"/>
-            <a:ext cx="2697480" cy="1645560"/>
+            <a:ext cx="2697120" cy="1645200"/>
           </a:xfrm>
           <a:prstGeom prst="rect">
             <a:avLst/>
@@ -7848,7 +7919,7 @@
         <p:spPr>
           <a:xfrm>
             <a:off x="457200" y="3273480"/>
-            <a:ext cx="8229240" cy="255600"/>
+            <a:ext cx="8228880" cy="255240"/>
           </a:xfrm>
           <a:prstGeom prst="rect">
             <a:avLst/>
@@ -7909,7 +7980,7 @@
         <p:spPr>
           <a:xfrm>
             <a:off x="457200" y="3566160"/>
-            <a:ext cx="8229240" cy="1188360"/>
+            <a:ext cx="8228880" cy="1188000"/>
           </a:xfrm>
           <a:prstGeom prst="rect">
             <a:avLst/>
@@ -8094,7 +8165,7 @@
         <p:spPr>
           <a:xfrm>
             <a:off x="274320" y="3200400"/>
-            <a:ext cx="4754880" cy="1942920"/>
+            <a:ext cx="4754520" cy="1942560"/>
           </a:xfrm>
           <a:prstGeom prst="rect">
             <a:avLst/>
@@ -8118,7 +8189,7 @@
         <p:spPr>
           <a:xfrm>
             <a:off x="5257800" y="3024000"/>
-            <a:ext cx="3657600" cy="2122200"/>
+            <a:ext cx="3657240" cy="2121840"/>
           </a:xfrm>
           <a:prstGeom prst="rect">
             <a:avLst/>
@@ -8175,7 +8246,7 @@
         <p:spPr>
           <a:xfrm>
             <a:off x="0" y="0"/>
-            <a:ext cx="9143640" cy="685440"/>
+            <a:ext cx="9143280" cy="685080"/>
           </a:xfrm>
           <a:prstGeom prst="rect">
             <a:avLst/>
@@ -8218,7 +8289,7 @@
         <p:spPr>
           <a:xfrm>
             <a:off x="274320" y="73080"/>
-            <a:ext cx="8595000" cy="548280"/>
+            <a:ext cx="8594640" cy="547920"/>
           </a:xfrm>
           <a:prstGeom prst="rect">
             <a:avLst/>
@@ -8279,7 +8350,7 @@
         <p:spPr>
           <a:xfrm>
             <a:off x="274320" y="777240"/>
-            <a:ext cx="4937400" cy="1919880"/>
+            <a:ext cx="4937040" cy="1919520"/>
           </a:xfrm>
           <a:prstGeom prst="rect">
             <a:avLst/>
@@ -8325,7 +8396,7 @@
         <p:spPr>
           <a:xfrm>
             <a:off x="365760" y="850320"/>
-            <a:ext cx="4754520" cy="1773720"/>
+            <a:ext cx="4754160" cy="1773360"/>
           </a:xfrm>
           <a:prstGeom prst="rect">
             <a:avLst/>
@@ -8554,7 +8625,7 @@
         <p:spPr>
           <a:xfrm>
             <a:off x="5394960" y="804600"/>
-            <a:ext cx="1691280" cy="822600"/>
+            <a:ext cx="1690920" cy="822240"/>
           </a:xfrm>
           <a:prstGeom prst="rect">
             <a:avLst/>
@@ -8600,7 +8671,7 @@
         <p:spPr>
           <a:xfrm>
             <a:off x="5440680" y="859680"/>
-            <a:ext cx="1599840" cy="255600"/>
+            <a:ext cx="1599480" cy="255240"/>
           </a:xfrm>
           <a:prstGeom prst="rect">
             <a:avLst/>
@@ -8661,7 +8732,7 @@
         <p:spPr>
           <a:xfrm>
             <a:off x="5440680" y="1152000"/>
-            <a:ext cx="1599840" cy="347040"/>
+            <a:ext cx="1599480" cy="346680"/>
           </a:xfrm>
           <a:prstGeom prst="rect">
             <a:avLst/>
@@ -8722,7 +8793,7 @@
         <p:spPr>
           <a:xfrm>
             <a:off x="7269480" y="804600"/>
-            <a:ext cx="1691280" cy="822600"/>
+            <a:ext cx="1690920" cy="822240"/>
           </a:xfrm>
           <a:prstGeom prst="rect">
             <a:avLst/>
@@ -8768,7 +8839,7 @@
         <p:spPr>
           <a:xfrm>
             <a:off x="7315200" y="859680"/>
-            <a:ext cx="1599840" cy="255600"/>
+            <a:ext cx="1599480" cy="255240"/>
           </a:xfrm>
           <a:prstGeom prst="rect">
             <a:avLst/>
@@ -8829,7 +8900,7 @@
         <p:spPr>
           <a:xfrm>
             <a:off x="7315200" y="1152000"/>
-            <a:ext cx="1599840" cy="347040"/>
+            <a:ext cx="1599480" cy="346680"/>
           </a:xfrm>
           <a:prstGeom prst="rect">
             <a:avLst/>
@@ -8890,7 +8961,7 @@
         <p:spPr>
           <a:xfrm>
             <a:off x="5394960" y="1764720"/>
-            <a:ext cx="1691280" cy="822600"/>
+            <a:ext cx="1690920" cy="822240"/>
           </a:xfrm>
           <a:prstGeom prst="rect">
             <a:avLst/>
@@ -8936,7 +9007,7 @@
         <p:spPr>
           <a:xfrm>
             <a:off x="5440680" y="1819800"/>
-            <a:ext cx="1599840" cy="255600"/>
+            <a:ext cx="1599480" cy="255240"/>
           </a:xfrm>
           <a:prstGeom prst="rect">
             <a:avLst/>
@@ -8997,7 +9068,7 @@
         <p:spPr>
           <a:xfrm>
             <a:off x="5440680" y="2112120"/>
-            <a:ext cx="1599840" cy="347040"/>
+            <a:ext cx="1599480" cy="346680"/>
           </a:xfrm>
           <a:prstGeom prst="rect">
             <a:avLst/>
@@ -9058,7 +9129,7 @@
         <p:spPr>
           <a:xfrm>
             <a:off x="7269480" y="1764720"/>
-            <a:ext cx="1691280" cy="822600"/>
+            <a:ext cx="1690920" cy="822240"/>
           </a:xfrm>
           <a:prstGeom prst="rect">
             <a:avLst/>
@@ -9104,7 +9175,7 @@
         <p:spPr>
           <a:xfrm>
             <a:off x="7315200" y="1819800"/>
-            <a:ext cx="1599840" cy="255600"/>
+            <a:ext cx="1599480" cy="255240"/>
           </a:xfrm>
           <a:prstGeom prst="rect">
             <a:avLst/>
@@ -9165,7 +9236,7 @@
         <p:spPr>
           <a:xfrm>
             <a:off x="7315200" y="2112120"/>
-            <a:ext cx="1599840" cy="347040"/>
+            <a:ext cx="1599480" cy="346680"/>
           </a:xfrm>
           <a:prstGeom prst="rect">
             <a:avLst/>
@@ -9226,7 +9297,7 @@
         <p:spPr>
           <a:xfrm>
             <a:off x="5394960" y="2724840"/>
-            <a:ext cx="1691280" cy="822600"/>
+            <a:ext cx="1690920" cy="822240"/>
           </a:xfrm>
           <a:prstGeom prst="rect">
             <a:avLst/>
@@ -9272,7 +9343,7 @@
         <p:spPr>
           <a:xfrm>
             <a:off x="5440680" y="2779920"/>
-            <a:ext cx="1599840" cy="255600"/>
+            <a:ext cx="1599480" cy="255240"/>
           </a:xfrm>
           <a:prstGeom prst="rect">
             <a:avLst/>
@@ -9333,7 +9404,7 @@
         <p:spPr>
           <a:xfrm>
             <a:off x="5440680" y="3072240"/>
-            <a:ext cx="1599840" cy="347040"/>
+            <a:ext cx="1599480" cy="346680"/>
           </a:xfrm>
           <a:prstGeom prst="rect">
             <a:avLst/>
@@ -9394,7 +9465,7 @@
         <p:spPr>
           <a:xfrm>
             <a:off x="7269480" y="2724840"/>
-            <a:ext cx="1691280" cy="822600"/>
+            <a:ext cx="1690920" cy="822240"/>
           </a:xfrm>
           <a:prstGeom prst="rect">
             <a:avLst/>
@@ -9440,7 +9511,7 @@
         <p:spPr>
           <a:xfrm>
             <a:off x="7315200" y="2779920"/>
-            <a:ext cx="1599840" cy="255600"/>
+            <a:ext cx="1599480" cy="255240"/>
           </a:xfrm>
           <a:prstGeom prst="rect">
             <a:avLst/>
@@ -9501,7 +9572,7 @@
         <p:spPr>
           <a:xfrm>
             <a:off x="7315200" y="3072240"/>
-            <a:ext cx="1599840" cy="347040"/>
+            <a:ext cx="1599480" cy="346680"/>
           </a:xfrm>
           <a:prstGeom prst="rect">
             <a:avLst/>
@@ -9562,7 +9633,7 @@
         <p:spPr>
           <a:xfrm>
             <a:off x="6309360" y="3684960"/>
-            <a:ext cx="1691280" cy="822600"/>
+            <a:ext cx="1690920" cy="822240"/>
           </a:xfrm>
           <a:prstGeom prst="rect">
             <a:avLst/>
@@ -9608,7 +9679,7 @@
         <p:spPr>
           <a:xfrm>
             <a:off x="6355080" y="3740040"/>
-            <a:ext cx="1599840" cy="255600"/>
+            <a:ext cx="1599480" cy="255240"/>
           </a:xfrm>
           <a:prstGeom prst="rect">
             <a:avLst/>
@@ -9669,7 +9740,7 @@
         <p:spPr>
           <a:xfrm>
             <a:off x="6355080" y="4032360"/>
-            <a:ext cx="1599840" cy="347040"/>
+            <a:ext cx="1599480" cy="346680"/>
           </a:xfrm>
           <a:prstGeom prst="rect">
             <a:avLst/>
@@ -9730,7 +9801,7 @@
         <p:spPr>
           <a:xfrm>
             <a:off x="274320" y="2880360"/>
-            <a:ext cx="4754520" cy="2011320"/>
+            <a:ext cx="4754160" cy="2010960"/>
           </a:xfrm>
           <a:prstGeom prst="rect">
             <a:avLst/>
@@ -9776,7 +9847,7 @@
         <p:spPr>
           <a:xfrm>
             <a:off x="457200" y="2944440"/>
-            <a:ext cx="4388760" cy="255600"/>
+            <a:ext cx="4388400" cy="255240"/>
           </a:xfrm>
           <a:prstGeom prst="rect">
             <a:avLst/>
@@ -9837,7 +9908,7 @@
         <p:spPr>
           <a:xfrm>
             <a:off x="457200" y="3227760"/>
-            <a:ext cx="4388760" cy="1599840"/>
+            <a:ext cx="4388400" cy="1599480"/>
           </a:xfrm>
           <a:prstGeom prst="rect">
             <a:avLst/>
@@ -10145,7 +10216,7 @@
         <p:spPr>
           <a:xfrm>
             <a:off x="0" y="0"/>
-            <a:ext cx="9143640" cy="685440"/>
+            <a:ext cx="9143280" cy="685080"/>
           </a:xfrm>
           <a:prstGeom prst="rect">
             <a:avLst/>
@@ -10188,7 +10259,7 @@
         <p:spPr>
           <a:xfrm>
             <a:off x="274320" y="73080"/>
-            <a:ext cx="8595000" cy="548280"/>
+            <a:ext cx="8594640" cy="547920"/>
           </a:xfrm>
           <a:prstGeom prst="rect">
             <a:avLst/>
@@ -10249,7 +10320,7 @@
         <p:spPr>
           <a:xfrm>
             <a:off x="274320" y="777240"/>
-            <a:ext cx="8595000" cy="822600"/>
+            <a:ext cx="8594640" cy="822240"/>
           </a:xfrm>
           <a:prstGeom prst="rect">
             <a:avLst/>
@@ -10295,7 +10366,7 @@
         <p:spPr>
           <a:xfrm>
             <a:off x="365760" y="850320"/>
-            <a:ext cx="8412120" cy="676440"/>
+            <a:ext cx="8411760" cy="676080"/>
           </a:xfrm>
           <a:prstGeom prst="rect">
             <a:avLst/>
@@ -10385,7 +10456,7 @@
         </p:nvGraphicFramePr>
         <p:xfrm>
           <a:off x="4572000" y="2057400"/>
-          <a:ext cx="4296600" cy="2833920"/>
+          <a:ext cx="4296240" cy="2834280"/>
         </p:xfrm>
         <a:graphic>
           <a:graphicData uri="http://schemas.openxmlformats.org/drawingml/2006/table">
@@ -13028,7 +13099,7 @@
         <p:spPr>
           <a:xfrm>
             <a:off x="0" y="685800"/>
-            <a:ext cx="9143640" cy="1371600"/>
+            <a:ext cx="9143280" cy="1371240"/>
           </a:xfrm>
           <a:prstGeom prst="rect">
             <a:avLst/>
@@ -13052,7 +13123,7 @@
         <p:spPr>
           <a:xfrm>
             <a:off x="0" y="2057400"/>
-            <a:ext cx="4572000" cy="3086280"/>
+            <a:ext cx="4571640" cy="3085920"/>
           </a:xfrm>
           <a:prstGeom prst="rect">
             <a:avLst/>
@@ -13109,7 +13180,7 @@
         <p:spPr>
           <a:xfrm>
             <a:off x="0" y="0"/>
-            <a:ext cx="9143640" cy="685440"/>
+            <a:ext cx="9143280" cy="685080"/>
           </a:xfrm>
           <a:prstGeom prst="rect">
             <a:avLst/>
@@ -13152,7 +13223,7 @@
         <p:spPr>
           <a:xfrm>
             <a:off x="274320" y="73080"/>
-            <a:ext cx="8595000" cy="548280"/>
+            <a:ext cx="8594640" cy="547920"/>
           </a:xfrm>
           <a:prstGeom prst="rect">
             <a:avLst/>
@@ -13213,7 +13284,7 @@
         <p:spPr>
           <a:xfrm>
             <a:off x="274320" y="777240"/>
-            <a:ext cx="4845960" cy="2742840"/>
+            <a:ext cx="4845600" cy="2742480"/>
           </a:xfrm>
           <a:prstGeom prst="rect">
             <a:avLst/>
@@ -13259,7 +13330,7 @@
         <p:spPr>
           <a:xfrm>
             <a:off x="365760" y="850320"/>
-            <a:ext cx="4663080" cy="2596680"/>
+            <a:ext cx="4662720" cy="2596320"/>
           </a:xfrm>
           <a:prstGeom prst="rect">
             <a:avLst/>
@@ -13596,7 +13667,7 @@
         <p:spPr>
           <a:xfrm>
             <a:off x="5303520" y="841320"/>
-            <a:ext cx="3657240" cy="411120"/>
+            <a:ext cx="3656880" cy="410760"/>
           </a:xfrm>
           <a:prstGeom prst="rect">
             <a:avLst/>
@@ -13642,7 +13713,7 @@
         <p:spPr>
           <a:xfrm>
             <a:off x="5303520" y="841320"/>
-            <a:ext cx="109440" cy="411120"/>
+            <a:ext cx="109080" cy="410760"/>
           </a:xfrm>
           <a:prstGeom prst="rect">
             <a:avLst/>
@@ -13685,7 +13756,7 @@
         <p:spPr>
           <a:xfrm>
             <a:off x="5486400" y="905400"/>
-            <a:ext cx="2011320" cy="273960"/>
+            <a:ext cx="2010960" cy="273600"/>
           </a:xfrm>
           <a:prstGeom prst="rect">
             <a:avLst/>
@@ -13746,7 +13817,7 @@
         <p:spPr>
           <a:xfrm>
             <a:off x="7772400" y="905400"/>
-            <a:ext cx="1096920" cy="273960"/>
+            <a:ext cx="1096560" cy="273600"/>
           </a:xfrm>
           <a:prstGeom prst="rect">
             <a:avLst/>
@@ -13807,7 +13878,7 @@
         <p:spPr>
           <a:xfrm>
             <a:off x="5303520" y="1344240"/>
-            <a:ext cx="3657240" cy="411120"/>
+            <a:ext cx="3656880" cy="410760"/>
           </a:xfrm>
           <a:prstGeom prst="rect">
             <a:avLst/>
@@ -13853,7 +13924,7 @@
         <p:spPr>
           <a:xfrm>
             <a:off x="5303520" y="1344240"/>
-            <a:ext cx="109440" cy="411120"/>
+            <a:ext cx="109080" cy="410760"/>
           </a:xfrm>
           <a:prstGeom prst="rect">
             <a:avLst/>
@@ -13896,7 +13967,7 @@
         <p:spPr>
           <a:xfrm>
             <a:off x="5486400" y="1408320"/>
-            <a:ext cx="2011320" cy="273960"/>
+            <a:ext cx="2010960" cy="273600"/>
           </a:xfrm>
           <a:prstGeom prst="rect">
             <a:avLst/>
@@ -13957,7 +14028,7 @@
         <p:spPr>
           <a:xfrm>
             <a:off x="7772400" y="1408320"/>
-            <a:ext cx="1096920" cy="273960"/>
+            <a:ext cx="1096560" cy="273600"/>
           </a:xfrm>
           <a:prstGeom prst="rect">
             <a:avLst/>
@@ -14018,7 +14089,7 @@
         <p:spPr>
           <a:xfrm>
             <a:off x="5303520" y="1847160"/>
-            <a:ext cx="3657240" cy="411120"/>
+            <a:ext cx="3656880" cy="410760"/>
           </a:xfrm>
           <a:prstGeom prst="rect">
             <a:avLst/>
@@ -14064,7 +14135,7 @@
         <p:spPr>
           <a:xfrm>
             <a:off x="5303520" y="1847160"/>
-            <a:ext cx="109440" cy="411120"/>
+            <a:ext cx="109080" cy="410760"/>
           </a:xfrm>
           <a:prstGeom prst="rect">
             <a:avLst/>
@@ -14107,7 +14178,7 @@
         <p:spPr>
           <a:xfrm>
             <a:off x="5486400" y="1911240"/>
-            <a:ext cx="2011320" cy="273960"/>
+            <a:ext cx="2010960" cy="273600"/>
           </a:xfrm>
           <a:prstGeom prst="rect">
             <a:avLst/>
@@ -14168,7 +14239,7 @@
         <p:spPr>
           <a:xfrm>
             <a:off x="7772400" y="1911240"/>
-            <a:ext cx="1096920" cy="273960"/>
+            <a:ext cx="1096560" cy="273600"/>
           </a:xfrm>
           <a:prstGeom prst="rect">
             <a:avLst/>
@@ -14229,7 +14300,7 @@
         <p:spPr>
           <a:xfrm>
             <a:off x="5303520" y="2350080"/>
-            <a:ext cx="3657240" cy="411120"/>
+            <a:ext cx="3656880" cy="410760"/>
           </a:xfrm>
           <a:prstGeom prst="rect">
             <a:avLst/>
@@ -14275,7 +14346,7 @@
         <p:spPr>
           <a:xfrm>
             <a:off x="5303520" y="2350080"/>
-            <a:ext cx="109440" cy="411120"/>
+            <a:ext cx="109080" cy="410760"/>
           </a:xfrm>
           <a:prstGeom prst="rect">
             <a:avLst/>
@@ -14318,7 +14389,7 @@
         <p:spPr>
           <a:xfrm>
             <a:off x="5486400" y="2414160"/>
-            <a:ext cx="2011320" cy="273960"/>
+            <a:ext cx="2010960" cy="273600"/>
           </a:xfrm>
           <a:prstGeom prst="rect">
             <a:avLst/>
@@ -14379,7 +14450,7 @@
         <p:spPr>
           <a:xfrm>
             <a:off x="7772400" y="2414160"/>
-            <a:ext cx="1096920" cy="273960"/>
+            <a:ext cx="1096560" cy="273600"/>
           </a:xfrm>
           <a:prstGeom prst="rect">
             <a:avLst/>
@@ -14440,7 +14511,7 @@
         <p:spPr>
           <a:xfrm>
             <a:off x="5303520" y="2853000"/>
-            <a:ext cx="3657240" cy="411120"/>
+            <a:ext cx="3656880" cy="410760"/>
           </a:xfrm>
           <a:prstGeom prst="rect">
             <a:avLst/>
@@ -14486,7 +14557,7 @@
         <p:spPr>
           <a:xfrm>
             <a:off x="5303520" y="2853000"/>
-            <a:ext cx="109440" cy="411120"/>
+            <a:ext cx="109080" cy="410760"/>
           </a:xfrm>
           <a:prstGeom prst="rect">
             <a:avLst/>
@@ -14529,7 +14600,7 @@
         <p:spPr>
           <a:xfrm>
             <a:off x="5486400" y="2917080"/>
-            <a:ext cx="2011320" cy="273960"/>
+            <a:ext cx="2010960" cy="273600"/>
           </a:xfrm>
           <a:prstGeom prst="rect">
             <a:avLst/>
@@ -14590,7 +14661,7 @@
         <p:spPr>
           <a:xfrm>
             <a:off x="7772400" y="2917080"/>
-            <a:ext cx="1096920" cy="273960"/>
+            <a:ext cx="1096560" cy="273600"/>
           </a:xfrm>
           <a:prstGeom prst="rect">
             <a:avLst/>
@@ -14651,7 +14722,7 @@
         <p:spPr>
           <a:xfrm>
             <a:off x="5303520" y="3566160"/>
-            <a:ext cx="3657240" cy="1371240"/>
+            <a:ext cx="3656880" cy="1370880"/>
           </a:xfrm>
           <a:prstGeom prst="rect">
             <a:avLst/>
@@ -14697,7 +14768,7 @@
         <p:spPr>
           <a:xfrm>
             <a:off x="5394960" y="3639240"/>
-            <a:ext cx="3474360" cy="1234080"/>
+            <a:ext cx="3474000" cy="1233720"/>
           </a:xfrm>
           <a:prstGeom prst="rect">
             <a:avLst/>
@@ -14852,7 +14923,7 @@
         <p:spPr>
           <a:xfrm>
             <a:off x="123120" y="797400"/>
-            <a:ext cx="4997160" cy="4231800"/>
+            <a:ext cx="4996800" cy="4231440"/>
           </a:xfrm>
           <a:prstGeom prst="rect">
             <a:avLst/>
@@ -14909,7 +14980,7 @@
         <p:spPr>
           <a:xfrm>
             <a:off x="0" y="0"/>
-            <a:ext cx="9143640" cy="685440"/>
+            <a:ext cx="9143280" cy="685080"/>
           </a:xfrm>
           <a:prstGeom prst="rect">
             <a:avLst/>
@@ -14952,7 +15023,7 @@
         <p:spPr>
           <a:xfrm>
             <a:off x="274320" y="73080"/>
-            <a:ext cx="8595000" cy="548280"/>
+            <a:ext cx="8594640" cy="547920"/>
           </a:xfrm>
           <a:prstGeom prst="rect">
             <a:avLst/>
@@ -15013,7 +15084,7 @@
         <p:spPr>
           <a:xfrm>
             <a:off x="274320" y="777240"/>
-            <a:ext cx="4845960" cy="2834280"/>
+            <a:ext cx="4845600" cy="2833920"/>
           </a:xfrm>
           <a:prstGeom prst="rect">
             <a:avLst/>
@@ -15059,7 +15130,7 @@
         <p:spPr>
           <a:xfrm>
             <a:off x="365760" y="850320"/>
-            <a:ext cx="4663080" cy="2688120"/>
+            <a:ext cx="4662720" cy="2687760"/>
           </a:xfrm>
           <a:prstGeom prst="rect">
             <a:avLst/>
@@ -15426,7 +15497,7 @@
         <p:spPr>
           <a:xfrm>
             <a:off x="5303520" y="822960"/>
-            <a:ext cx="3657240" cy="868320"/>
+            <a:ext cx="3656880" cy="867960"/>
           </a:xfrm>
           <a:prstGeom prst="rect">
             <a:avLst/>
@@ -15472,7 +15543,7 @@
         <p:spPr>
           <a:xfrm>
             <a:off x="5440680" y="887040"/>
-            <a:ext cx="1645560" cy="319680"/>
+            <a:ext cx="1645200" cy="319320"/>
           </a:xfrm>
           <a:prstGeom prst="rect">
             <a:avLst/>
@@ -15533,7 +15604,7 @@
         <p:spPr>
           <a:xfrm>
             <a:off x="5440680" y="1234440"/>
-            <a:ext cx="1828440" cy="273960"/>
+            <a:ext cx="1828080" cy="273600"/>
           </a:xfrm>
           <a:prstGeom prst="rect">
             <a:avLst/>
@@ -15594,7 +15665,7 @@
         <p:spPr>
           <a:xfrm>
             <a:off x="7223760" y="1051560"/>
-            <a:ext cx="1645560" cy="411120"/>
+            <a:ext cx="1645200" cy="410760"/>
           </a:xfrm>
           <a:prstGeom prst="rect">
             <a:avLst/>
@@ -15655,7 +15726,7 @@
         <p:spPr>
           <a:xfrm>
             <a:off x="5303520" y="1828800"/>
-            <a:ext cx="3657240" cy="868320"/>
+            <a:ext cx="3656880" cy="867960"/>
           </a:xfrm>
           <a:prstGeom prst="rect">
             <a:avLst/>
@@ -15701,7 +15772,7 @@
         <p:spPr>
           <a:xfrm>
             <a:off x="5440680" y="1892880"/>
-            <a:ext cx="1645560" cy="319680"/>
+            <a:ext cx="1645200" cy="319320"/>
           </a:xfrm>
           <a:prstGeom prst="rect">
             <a:avLst/>
@@ -15762,7 +15833,7 @@
         <p:spPr>
           <a:xfrm>
             <a:off x="5440680" y="2240280"/>
-            <a:ext cx="1828440" cy="273960"/>
+            <a:ext cx="1828080" cy="273600"/>
           </a:xfrm>
           <a:prstGeom prst="rect">
             <a:avLst/>
@@ -15823,7 +15894,7 @@
         <p:spPr>
           <a:xfrm>
             <a:off x="7223760" y="2057400"/>
-            <a:ext cx="1645560" cy="411120"/>
+            <a:ext cx="1645200" cy="410760"/>
           </a:xfrm>
           <a:prstGeom prst="rect">
             <a:avLst/>
@@ -15884,7 +15955,7 @@
         <p:spPr>
           <a:xfrm>
             <a:off x="5303520" y="2834640"/>
-            <a:ext cx="3657240" cy="868320"/>
+            <a:ext cx="3656880" cy="867960"/>
           </a:xfrm>
           <a:prstGeom prst="rect">
             <a:avLst/>
@@ -15930,7 +16001,7 @@
         <p:spPr>
           <a:xfrm>
             <a:off x="5440680" y="2898720"/>
-            <a:ext cx="1645560" cy="319680"/>
+            <a:ext cx="1645200" cy="319320"/>
           </a:xfrm>
           <a:prstGeom prst="rect">
             <a:avLst/>
@@ -15991,7 +16062,7 @@
         <p:spPr>
           <a:xfrm>
             <a:off x="5440680" y="3246120"/>
-            <a:ext cx="1828440" cy="273960"/>
+            <a:ext cx="1828080" cy="273600"/>
           </a:xfrm>
           <a:prstGeom prst="rect">
             <a:avLst/>
@@ -16052,7 +16123,7 @@
         <p:spPr>
           <a:xfrm>
             <a:off x="7223760" y="3063240"/>
-            <a:ext cx="1645560" cy="411120"/>
+            <a:ext cx="1645200" cy="410760"/>
           </a:xfrm>
           <a:prstGeom prst="rect">
             <a:avLst/>
@@ -16113,7 +16184,7 @@
         <p:spPr>
           <a:xfrm>
             <a:off x="5303520" y="3840480"/>
-            <a:ext cx="3657240" cy="868320"/>
+            <a:ext cx="3656880" cy="867960"/>
           </a:xfrm>
           <a:prstGeom prst="rect">
             <a:avLst/>
@@ -16159,7 +16230,7 @@
         <p:spPr>
           <a:xfrm>
             <a:off x="5440680" y="3904560"/>
-            <a:ext cx="1645560" cy="319680"/>
+            <a:ext cx="1645200" cy="319320"/>
           </a:xfrm>
           <a:prstGeom prst="rect">
             <a:avLst/>
@@ -16220,7 +16291,7 @@
         <p:spPr>
           <a:xfrm>
             <a:off x="5440680" y="4251960"/>
-            <a:ext cx="1828440" cy="273960"/>
+            <a:ext cx="1828080" cy="273600"/>
           </a:xfrm>
           <a:prstGeom prst="rect">
             <a:avLst/>
@@ -16281,7 +16352,7 @@
         <p:spPr>
           <a:xfrm>
             <a:off x="7223760" y="4069080"/>
-            <a:ext cx="1645560" cy="411120"/>
+            <a:ext cx="1645200" cy="410760"/>
           </a:xfrm>
           <a:prstGeom prst="rect">
             <a:avLst/>
@@ -16346,7 +16417,7 @@
         <p:spPr>
           <a:xfrm>
             <a:off x="0" y="790920"/>
-            <a:ext cx="5120280" cy="3552480"/>
+            <a:ext cx="5119920" cy="3552120"/>
           </a:xfrm>
           <a:prstGeom prst="rect">
             <a:avLst/>
@@ -16403,7 +16474,7 @@
         <p:spPr>
           <a:xfrm>
             <a:off x="0" y="0"/>
-            <a:ext cx="9143640" cy="685440"/>
+            <a:ext cx="9143280" cy="685080"/>
           </a:xfrm>
           <a:prstGeom prst="rect">
             <a:avLst/>
@@ -16446,7 +16517,7 @@
         <p:spPr>
           <a:xfrm>
             <a:off x="274320" y="73080"/>
-            <a:ext cx="8595000" cy="548280"/>
+            <a:ext cx="8594640" cy="547920"/>
           </a:xfrm>
           <a:prstGeom prst="rect">
             <a:avLst/>
@@ -16507,7 +16578,7 @@
         <p:spPr>
           <a:xfrm>
             <a:off x="274320" y="777240"/>
-            <a:ext cx="4845960" cy="3017160"/>
+            <a:ext cx="4845600" cy="3016800"/>
           </a:xfrm>
           <a:prstGeom prst="rect">
             <a:avLst/>
@@ -16553,7 +16624,7 @@
         <p:spPr>
           <a:xfrm>
             <a:off x="365760" y="850320"/>
-            <a:ext cx="4663080" cy="2871000"/>
+            <a:ext cx="4662720" cy="2870640"/>
           </a:xfrm>
           <a:prstGeom prst="rect">
             <a:avLst/>
@@ -18404,7 +18475,7 @@
         <p:spPr>
           <a:xfrm>
             <a:off x="5303520" y="3246120"/>
-            <a:ext cx="3657240" cy="1645560"/>
+            <a:ext cx="3656880" cy="1645200"/>
           </a:xfrm>
           <a:prstGeom prst="rect">
             <a:avLst/>
@@ -18450,7 +18521,7 @@
         <p:spPr>
           <a:xfrm>
             <a:off x="5440680" y="3337560"/>
-            <a:ext cx="3382920" cy="1462680"/>
+            <a:ext cx="3382560" cy="1462320"/>
           </a:xfrm>
           <a:prstGeom prst="rect">
             <a:avLst/>
@@ -18605,7 +18676,7 @@
         <p:spPr>
           <a:xfrm>
             <a:off x="228600" y="800280"/>
-            <a:ext cx="4891680" cy="4000320"/>
+            <a:ext cx="4891320" cy="3999960"/>
           </a:xfrm>
           <a:prstGeom prst="rect">
             <a:avLst/>

</xml_diff>